<commit_message>
Update presentation cover for five group members
</commit_message>
<xml_diff>
--- a/presentation/Financial_SDE_Numerical_Methods_Presentation_Editable.pptx
+++ b/presentation/Financial_SDE_Numerical_Methods_Presentation_Editable.pptx
@@ -7264,8 +7264,8 @@
         </p:nvSpPr>
         <p:spPr>
           <a:xfrm>
-            <a:off x="1828800" y="3246120"/>
-            <a:ext cx="8531352" cy="384048"/>
+            <a:off x="1828800" y="2999232"/>
+            <a:ext cx="8531352" cy="292608"/>
           </a:xfrm>
           <a:prstGeom prst="rect">
             <a:avLst/>
@@ -7283,17 +7283,17 @@
               <a:buNone/>
             </a:pPr>
             <a:r>
-              <a:rPr lang="en-US" sz="1600" dirty="0">
-                <a:solidFill>
-                  <a:srgbClr val="17212B"/>
+              <a:rPr lang="en-US" sz="1550" b="1" dirty="0">
+                <a:solidFill>
+                  <a:srgbClr val="17365D"/>
                 </a:solidFill>
                 <a:latin typeface="Aptos" pitchFamily="34" charset="0"/>
                 <a:ea typeface="Aptos" pitchFamily="34" charset="-122"/>
                 <a:cs typeface="Aptos" pitchFamily="34" charset="-120"/>
               </a:rPr>
-              <a:t>Name: ____________________      Student ID: ____________________</a:t>
-            </a:r>
-            <a:endParaRPr lang="en-US" sz="1600" dirty="0"/>
+              <a:t>Group Members</a:t>
+            </a:r>
+            <a:endParaRPr lang="en-US" sz="1550" dirty="0"/>
           </a:p>
         </p:txBody>
       </p:sp>
@@ -7305,8 +7305,117 @@
         </p:nvSpPr>
         <p:spPr>
           <a:xfrm>
-            <a:off x="1828800" y="3886200"/>
-            <a:ext cx="8531352" cy="365760"/>
+            <a:off x="1828800" y="3328416"/>
+            <a:ext cx="8531352" cy="1481328"/>
+          </a:xfrm>
+          <a:prstGeom prst="rect">
+            <a:avLst/>
+          </a:prstGeom>
+          <a:noFill/>
+          <a:ln/>
+        </p:spPr>
+        <p:txBody>
+          <a:bodyPr wrap="square" lIns="762" tIns="762" rIns="762" bIns="762" rtlCol="0" anchor="ctr">
+            <a:normAutofit/>
+          </a:bodyPr>
+          <a:lstStyle/>
+          <a:p>
+            <a:pPr algn="ctr" indent="0" marL="0">
+              <a:buNone/>
+            </a:pPr>
+            <a:r>
+              <a:rPr lang="en-US" sz="1350" dirty="0">
+                <a:solidFill>
+                  <a:srgbClr val="17212B"/>
+                </a:solidFill>
+                <a:latin typeface="Aptos" pitchFamily="34" charset="0"/>
+                <a:ea typeface="Aptos" pitchFamily="34" charset="-122"/>
+                <a:cs typeface="Aptos" pitchFamily="34" charset="-120"/>
+              </a:rPr>
+              <a:t>Member 1: ____________________    Student ID: ____________________</a:t>
+            </a:r>
+            <a:endParaRPr lang="en-US" sz="1350" dirty="0"/>
+          </a:p>
+          <a:p>
+            <a:pPr algn="ctr" indent="0" marL="0">
+              <a:buNone/>
+            </a:pPr>
+            <a:r>
+              <a:rPr lang="en-US" sz="1350" dirty="0">
+                <a:solidFill>
+                  <a:srgbClr val="17212B"/>
+                </a:solidFill>
+                <a:latin typeface="Aptos" pitchFamily="34" charset="0"/>
+                <a:ea typeface="Aptos" pitchFamily="34" charset="-122"/>
+                <a:cs typeface="Aptos" pitchFamily="34" charset="-120"/>
+              </a:rPr>
+              <a:t>Member 2: ____________________    Student ID: ____________________</a:t>
+            </a:r>
+            <a:endParaRPr lang="en-US" sz="1350" dirty="0"/>
+          </a:p>
+          <a:p>
+            <a:pPr algn="ctr" indent="0" marL="0">
+              <a:buNone/>
+            </a:pPr>
+            <a:r>
+              <a:rPr lang="en-US" sz="1350" dirty="0">
+                <a:solidFill>
+                  <a:srgbClr val="17212B"/>
+                </a:solidFill>
+                <a:latin typeface="Aptos" pitchFamily="34" charset="0"/>
+                <a:ea typeface="Aptos" pitchFamily="34" charset="-122"/>
+                <a:cs typeface="Aptos" pitchFamily="34" charset="-120"/>
+              </a:rPr>
+              <a:t>Member 3: ____________________    Student ID: ____________________</a:t>
+            </a:r>
+            <a:endParaRPr lang="en-US" sz="1350" dirty="0"/>
+          </a:p>
+          <a:p>
+            <a:pPr algn="ctr" indent="0" marL="0">
+              <a:buNone/>
+            </a:pPr>
+            <a:r>
+              <a:rPr lang="en-US" sz="1350" dirty="0">
+                <a:solidFill>
+                  <a:srgbClr val="17212B"/>
+                </a:solidFill>
+                <a:latin typeface="Aptos" pitchFamily="34" charset="0"/>
+                <a:ea typeface="Aptos" pitchFamily="34" charset="-122"/>
+                <a:cs typeface="Aptos" pitchFamily="34" charset="-120"/>
+              </a:rPr>
+              <a:t>Member 4: ____________________    Student ID: ____________________</a:t>
+            </a:r>
+            <a:endParaRPr lang="en-US" sz="1350" dirty="0"/>
+          </a:p>
+          <a:p>
+            <a:pPr algn="ctr" indent="0" marL="0">
+              <a:buNone/>
+            </a:pPr>
+            <a:r>
+              <a:rPr lang="en-US" sz="1350" dirty="0">
+                <a:solidFill>
+                  <a:srgbClr val="17212B"/>
+                </a:solidFill>
+                <a:latin typeface="Aptos" pitchFamily="34" charset="0"/>
+                <a:ea typeface="Aptos" pitchFamily="34" charset="-122"/>
+                <a:cs typeface="Aptos" pitchFamily="34" charset="-120"/>
+              </a:rPr>
+              <a:t>Member 5: ____________________    Student ID: ____________________</a:t>
+            </a:r>
+            <a:endParaRPr lang="en-US" sz="1350" dirty="0"/>
+          </a:p>
+        </p:txBody>
+      </p:sp>
+      <p:sp>
+        <p:nvSpPr>
+          <p:cNvPr id="7" name="Text 5"/>
+          <p:cNvSpPr/>
+          <p:nvPr/>
+        </p:nvSpPr>
+        <p:spPr>
+          <a:xfrm>
+            <a:off x="1828800" y="5047488"/>
+            <a:ext cx="8531352" cy="310896"/>
           </a:xfrm>
           <a:prstGeom prst="rect">
             <a:avLst/>
@@ -7324,7 +7433,7 @@
               <a:buNone/>
             </a:pPr>
             <a:r>
-              <a:rPr lang="en-US" sz="1600" dirty="0">
+              <a:rPr lang="en-US" sz="1400" dirty="0">
                 <a:solidFill>
                   <a:srgbClr val="556575"/>
                 </a:solidFill>
@@ -7334,20 +7443,20 @@
               </a:rPr>
               <a:t>Numerical Partial Differential Equations</a:t>
             </a:r>
-            <a:endParaRPr lang="en-US" sz="1600" dirty="0"/>
-          </a:p>
-        </p:txBody>
-      </p:sp>
-      <p:sp>
-        <p:nvSpPr>
-          <p:cNvPr id="7" name="Text 5"/>
-          <p:cNvSpPr/>
-          <p:nvPr/>
-        </p:nvSpPr>
-        <p:spPr>
-          <a:xfrm>
-            <a:off x="1828800" y="4407408"/>
-            <a:ext cx="8531352" cy="365760"/>
+            <a:endParaRPr lang="en-US" sz="1400" dirty="0"/>
+          </a:p>
+        </p:txBody>
+      </p:sp>
+      <p:sp>
+        <p:nvSpPr>
+          <p:cNvPr id="8" name="Text 6"/>
+          <p:cNvSpPr/>
+          <p:nvPr/>
+        </p:nvSpPr>
+        <p:spPr>
+          <a:xfrm>
+            <a:off x="1828800" y="5413248"/>
+            <a:ext cx="8531352" cy="292608"/>
           </a:xfrm>
           <a:prstGeom prst="rect">
             <a:avLst/>
@@ -7365,7 +7474,7 @@
               <a:buNone/>
             </a:pPr>
             <a:r>
-              <a:rPr lang="en-US" sz="1500" dirty="0">
+              <a:rPr lang="en-US" sz="1350" dirty="0">
                 <a:solidFill>
                   <a:srgbClr val="556575"/>
                 </a:solidFill>
@@ -7375,19 +7484,19 @@
               </a:rPr>
               <a:t>September 2026</a:t>
             </a:r>
-            <a:endParaRPr lang="en-US" sz="1500" dirty="0"/>
-          </a:p>
-        </p:txBody>
-      </p:sp>
-      <p:sp>
-        <p:nvSpPr>
-          <p:cNvPr id="8" name="Shape 6"/>
-          <p:cNvSpPr/>
-          <p:nvPr/>
-        </p:nvSpPr>
-        <p:spPr>
-          <a:xfrm>
-            <a:off x="3291840" y="5074920"/>
+            <a:endParaRPr lang="en-US" sz="1350" dirty="0"/>
+          </a:p>
+        </p:txBody>
+      </p:sp>
+      <p:sp>
+        <p:nvSpPr>
+          <p:cNvPr id="9" name="Shape 7"/>
+          <p:cNvSpPr/>
+          <p:nvPr/>
+        </p:nvSpPr>
+        <p:spPr>
+          <a:xfrm>
+            <a:off x="3291840" y="5870448"/>
             <a:ext cx="5605272" cy="0"/>
           </a:xfrm>
           <a:prstGeom prst="line">

</xml_diff>